<commit_message>
updated deck & progress tracking
</commit_message>
<xml_diff>
--- a/presentation/capacitacion_appraisal/ILO_Appraisal_GPT_Training_Ahmed_EN.pptx
+++ b/presentation/capacitacion_appraisal/ILO_Appraisal_GPT_Training_Ahmed_EN.pptx
@@ -12226,12 +12226,12 @@
           <a:p>
             <a:pPr/>
             <a:r>
-              <a:rPr sz="3600" b="1">
+              <a:rPr sz="4600" b="1">
                 <a:solidFill>
                   <a:srgbClr val="FFFFFF"/>
                 </a:solidFill>
               </a:rPr>
-              <a:t>Step 4 · The Excel: sheet «Resultado Diagnostico»</a:t>
+              <a:t>Step 4 · The results Excel</a:t>
             </a:r>
           </a:p>
         </p:txBody>
@@ -12245,7 +12245,7 @@
         <p:spPr>
           <a:xfrm>
             <a:off x="502920" y="1170432"/>
-            <a:ext cx="11183112" cy="685800"/>
+            <a:ext cx="11183112" cy="1051560"/>
           </a:xfrm>
           <a:prstGeom prst="rect">
             <a:avLst/>
@@ -12260,24 +12260,47 @@
           <a:p>
             <a:pPr>
               <a:spcAft>
-                <a:spcPts val="490"/>
+                <a:spcPts val="480"/>
               </a:spcAft>
             </a:pPr>
             <a:r>
-              <a:rPr sz="2100" b="1">
+              <a:rPr sz="1600" b="1">
                 <a:solidFill>
                   <a:srgbClr val="003E7E"/>
                 </a:solidFill>
               </a:rPr>
-              <a:t>A single sheet</a:t>
-            </a:r>
-            <a:r>
-              <a:rPr sz="2100" b="0">
+              <a:t>Sheet 1 · «Resultado Diagnostico»</a:t>
+            </a:r>
+            <a:r>
+              <a:rPr sz="1600" b="0">
                 <a:solidFill>
                   <a:srgbClr val="4A4A4A"/>
                 </a:solidFill>
               </a:rPr>
-              <a:t>, one row per criterion assessed. It is the auditable record: keep it.</a:t>
+              <a:t>  — one row per criterion assessed. It is the auditable record: keep it.</a:t>
+            </a:r>
+          </a:p>
+          <a:p>
+            <a:pPr>
+              <a:spcAft>
+                <a:spcPts val="480"/>
+              </a:spcAft>
+            </a:pPr>
+            <a:r>
+              <a:rPr sz="1600" b="1">
+                <a:solidFill>
+                  <a:srgbClr val="003E7E"/>
+                </a:solidFill>
+              </a:rPr>
+              <a:t>Sheet 2 · «Rubrica aplicada»</a:t>
+            </a:r>
+            <a:r>
+              <a:rPr sz="1600" b="0">
+                <a:solidFill>
+                  <a:srgbClr val="4A4A4A"/>
+                </a:solidFill>
+              </a:rPr>
+              <a:t>  — the definition of each criterion assessed: its checks and its decision rules.</a:t>
             </a:r>
           </a:p>
         </p:txBody>
@@ -12291,8 +12314,8 @@
           <p:nvPr/>
         </p:nvGraphicFramePr>
         <p:xfrm>
-          <a:off x="502920" y="1874519"/>
-          <a:ext cx="11183110" cy="3813045"/>
+          <a:off x="502920" y="2212848"/>
+          <a:ext cx="11183110" cy="3474716"/>
         </p:xfrm>
         <a:graphic>
           <a:graphicData uri="http://schemas.openxmlformats.org/drawingml/2006/table">
@@ -12305,7 +12328,7 @@
                 <a:gridCol w="4985242"/>
                 <a:gridCol w="3503143"/>
               </a:tblGrid>
-              <a:tr h="457565">
+              <a:tr h="416966">
                 <a:tc>
                   <a:txBody>
                     <a:bodyPr/>
@@ -12313,7 +12336,7 @@
                     <a:p>
                       <a:pPr/>
                       <a:r>
-                        <a:rPr b="1" sz="2100">
+                        <a:rPr b="1" sz="1900">
                           <a:solidFill>
                             <a:srgbClr val="FFFFFF"/>
                           </a:solidFill>
@@ -12335,7 +12358,7 @@
                     <a:p>
                       <a:pPr/>
                       <a:r>
-                        <a:rPr b="1" sz="2100">
+                        <a:rPr b="1" sz="1900">
                           <a:solidFill>
                             <a:srgbClr val="FFFFFF"/>
                           </a:solidFill>
@@ -12357,7 +12380,7 @@
                     <a:p>
                       <a:pPr/>
                       <a:r>
-                        <a:rPr b="1" sz="2100">
+                        <a:rPr b="1" sz="1900">
                           <a:solidFill>
                             <a:srgbClr val="FFFFFF"/>
                           </a:solidFill>
@@ -12373,7 +12396,7 @@
                   </a:tcPr>
                 </a:tc>
               </a:tr>
-              <a:tr h="671096">
+              <a:tr h="611550">
                 <a:tc>
                   <a:txBody>
                     <a:bodyPr/>
@@ -12381,7 +12404,7 @@
                     <a:p>
                       <a:pPr/>
                       <a:r>
-                        <a:rPr sz="2100" b="1">
+                        <a:rPr sz="1900" b="1">
                           <a:solidFill>
                             <a:srgbClr val="003E7E"/>
                           </a:solidFill>
@@ -12403,7 +12426,7 @@
                     <a:p>
                       <a:pPr/>
                       <a:r>
-                        <a:rPr sz="2100">
+                        <a:rPr sz="1900">
                           <a:solidFill>
                             <a:srgbClr val="4A4A4A"/>
                           </a:solidFill>
@@ -12425,7 +12448,7 @@
                     <a:p>
                       <a:pPr/>
                       <a:r>
-                        <a:rPr sz="2100">
+                        <a:rPr sz="1900">
                           <a:solidFill>
                             <a:srgbClr val="4A4A4A"/>
                           </a:solidFill>
@@ -12441,7 +12464,7 @@
                   </a:tcPr>
                 </a:tc>
               </a:tr>
-              <a:tr h="671096">
+              <a:tr h="611550">
                 <a:tc>
                   <a:txBody>
                     <a:bodyPr/>
@@ -12449,7 +12472,7 @@
                     <a:p>
                       <a:pPr/>
                       <a:r>
-                        <a:rPr sz="2100" b="1">
+                        <a:rPr sz="1900" b="1">
                           <a:solidFill>
                             <a:srgbClr val="003E7E"/>
                           </a:solidFill>
@@ -12471,7 +12494,7 @@
                     <a:p>
                       <a:pPr/>
                       <a:r>
-                        <a:rPr sz="2100">
+                        <a:rPr sz="1900">
                           <a:solidFill>
                             <a:srgbClr val="4A4A4A"/>
                           </a:solidFill>
@@ -12493,7 +12516,7 @@
                     <a:p>
                       <a:pPr/>
                       <a:r>
-                        <a:rPr sz="2100">
+                        <a:rPr sz="1900">
                           <a:solidFill>
                             <a:srgbClr val="4A4A4A"/>
                           </a:solidFill>
@@ -12509,7 +12532,7 @@
                   </a:tcPr>
                 </a:tc>
               </a:tr>
-              <a:tr h="671096">
+              <a:tr h="611550">
                 <a:tc>
                   <a:txBody>
                     <a:bodyPr/>
@@ -12517,7 +12540,7 @@
                     <a:p>
                       <a:pPr/>
                       <a:r>
-                        <a:rPr sz="2100" b="1">
+                        <a:rPr sz="1900" b="1">
                           <a:solidFill>
                             <a:srgbClr val="003E7E"/>
                           </a:solidFill>
@@ -12539,7 +12562,7 @@
                     <a:p>
                       <a:pPr/>
                       <a:r>
-                        <a:rPr sz="2100">
+                        <a:rPr sz="1900">
                           <a:solidFill>
                             <a:srgbClr val="4A4A4A"/>
                           </a:solidFill>
@@ -12561,7 +12584,7 @@
                     <a:p>
                       <a:pPr/>
                       <a:r>
-                        <a:rPr sz="2100">
+                        <a:rPr sz="1900">
                           <a:solidFill>
                             <a:srgbClr val="4A4A4A"/>
                           </a:solidFill>
@@ -12577,7 +12600,7 @@
                   </a:tcPr>
                 </a:tc>
               </a:tr>
-              <a:tr h="671096">
+              <a:tr h="611550">
                 <a:tc>
                   <a:txBody>
                     <a:bodyPr/>
@@ -12585,7 +12608,7 @@
                     <a:p>
                       <a:pPr/>
                       <a:r>
-                        <a:rPr sz="2100" b="1">
+                        <a:rPr sz="1900" b="1">
                           <a:solidFill>
                             <a:srgbClr val="003E7E"/>
                           </a:solidFill>
@@ -12607,7 +12630,7 @@
                     <a:p>
                       <a:pPr/>
                       <a:r>
-                        <a:rPr sz="2100">
+                        <a:rPr sz="1900">
                           <a:solidFill>
                             <a:srgbClr val="4A4A4A"/>
                           </a:solidFill>
@@ -12629,7 +12652,7 @@
                     <a:p>
                       <a:pPr/>
                       <a:r>
-                        <a:rPr sz="2100">
+                        <a:rPr sz="1900">
                           <a:solidFill>
                             <a:srgbClr val="4A4A4A"/>
                           </a:solidFill>
@@ -12645,7 +12668,7 @@
                   </a:tcPr>
                 </a:tc>
               </a:tr>
-              <a:tr h="671096">
+              <a:tr h="611550">
                 <a:tc>
                   <a:txBody>
                     <a:bodyPr/>
@@ -12653,7 +12676,7 @@
                     <a:p>
                       <a:pPr/>
                       <a:r>
-                        <a:rPr sz="2100" b="1">
+                        <a:rPr sz="1900" b="1">
                           <a:solidFill>
                             <a:srgbClr val="003E7E"/>
                           </a:solidFill>
@@ -12675,7 +12698,7 @@
                     <a:p>
                       <a:pPr/>
                       <a:r>
-                        <a:rPr sz="2100" b="1">
+                        <a:rPr sz="1900" b="1">
                           <a:solidFill>
                             <a:srgbClr val="D6001C"/>
                           </a:solidFill>
@@ -12697,7 +12720,7 @@
                     <a:p>
                       <a:pPr/>
                       <a:r>
-                        <a:rPr sz="2100">
+                        <a:rPr sz="1900">
                           <a:solidFill>
                             <a:srgbClr val="4A4A4A"/>
                           </a:solidFill>
@@ -12759,28 +12782,20 @@
           <a:p>
             <a:pPr algn="ctr"/>
             <a:r>
-              <a:rPr sz="2000" b="1">
+              <a:rPr sz="1900" b="1">
                 <a:solidFill>
                   <a:srgbClr val="003E7E"/>
                 </a:solidFill>
               </a:rPr>
-              <a:t>Column headers are in Spanish, as the file produces them.  </a:t>
-            </a:r>
-            <a:r>
-              <a:rPr sz="2000" b="1">
-                <a:solidFill>
-                  <a:srgbClr val="D6001C"/>
-                </a:solidFill>
-              </a:rPr>
-              <a:t>«Not Found» is not «No»: </a:t>
-            </a:r>
-            <a:r>
-              <a:rPr sz="2000" b="0">
+              <a:t>Sheet 2 makes the file self-contained:  </a:t>
+            </a:r>
+            <a:r>
+              <a:rPr sz="1900" b="0">
                 <a:solidFill>
                   <a:srgbClr val="4A4A4A"/>
                 </a:solidFill>
               </a:rPr>
-              <a:t>«No» says the criterion is not met; «Not Found» says the document does not let you tell.</a:t>
+              <a:t>an auditor sees the rule next to the verdict, without opening the rubric separately. Column headers are in Spanish, as the file produces them.</a:t>
             </a:r>
           </a:p>
         </p:txBody>
@@ -13792,7 +13807,7 @@
                   <a:srgbClr val="D6001C"/>
                 </a:solidFill>
               </a:rPr>
-              <a:t>Never accept an answer without opening the evidence. </a:t>
+              <a:t>«Not Found» is not «No»:  </a:t>
             </a:r>
             <a:r>
               <a:rPr sz="2000" b="0">
@@ -13800,7 +13815,7 @@
                   <a:srgbClr val="4A4A4A"/>
                 </a:solidFill>
               </a:rPr>
-              <a:t>The evidence is what turns an automated result into a defensible diagnosis.</a:t>
+              <a:t>«No» says the criterion is not met; «Not Found» says the document does not let you tell. And never accept an answer without opening the evidence.</a:t>
             </a:r>
           </a:p>
         </p:txBody>

</xml_diff>